<commit_message>
v3 - 1 slide per area (A), 1 combined slide (B), fixed colW, zero garbage
</commit_message>
<xml_diff>
--- a/MBR_VersionA_Template.pptx
+++ b/MBR_VersionA_Template.pptx
@@ -1211,7 +1211,7 @@
         </p:nvGraphicFramePr>
         <p:xfrm>
           <a:off x="182880" y="1335024"/>
-          <a:ext cx="3291840" cy="914400"/>
+          <a:ext cx="2971800" cy="914400"/>
         </p:xfrm>
         <a:graphic>
           <a:graphicData uri="http://schemas.openxmlformats.org/drawingml/2006/table">
@@ -1219,11 +1219,11 @@
               <a:tblPr/>
               <a:tblGrid>
                 <a:gridCol w="45720"/>
-                <a:gridCol w="1005840"/>
+                <a:gridCol w="960120"/>
                 <a:gridCol w="457200"/>
                 <a:gridCol w="457200"/>
                 <a:gridCol w="457200"/>
-                <a:gridCol w="548640"/>
+                <a:gridCol w="594360"/>
               </a:tblGrid>
               <a:tr h="228600">
                 <a:tc>
@@ -2352,7 +2352,7 @@
                           <a:ea typeface="Arial" pitchFamily="34" charset="-122"/>
                           <a:cs typeface="Arial" pitchFamily="34" charset="-120"/>
                         </a:rPr>
-                        <a:t>Urban Combined</a:t>
+                        <a:t>Urban</a:t>
                       </a:r>
                       <a:endParaRPr lang="en-US" sz="800" dirty="0">
                         <a:latin typeface="Arial" charset="0"/>
@@ -2789,7 +2789,7 @@
                       <a:pPr algn="ctr" indent="0" marL="0">
                         <a:buNone/>
                       </a:pPr>
-                      <a:endParaRPr lang="en-US" sz="800" dirty="0">
+                      <a:endParaRPr lang="en-US" sz="700" dirty="0">
                         <a:latin typeface="Arial" charset="0"/>
                         <a:ea typeface="Arial" charset="0"/>
                         <a:cs typeface="Arial" charset="0"/>
@@ -2844,9 +2844,9 @@
                         <a:buNone/>
                       </a:pPr>
                       <a:r>
-                        <a:rPr lang="en-US" sz="800" dirty="0">
+                        <a:rPr lang="en-US" sz="700" dirty="0">
                           <a:solidFill>
-                            <a:srgbClr val="000000"/>
+                            <a:srgbClr val="808080"/>
                           </a:solidFill>
                           <a:latin typeface="Arial" pitchFamily="34" charset="0"/>
                           <a:ea typeface="Arial" pitchFamily="34" charset="-122"/>
@@ -2854,7 +2854,7 @@
                         </a:rPr>
                         <a:t>11.6</a:t>
                       </a:r>
-                      <a:endParaRPr lang="en-US" sz="800" dirty="0">
+                      <a:endParaRPr lang="en-US" sz="700" dirty="0">
                         <a:latin typeface="Arial" charset="0"/>
                         <a:ea typeface="Arial" charset="0"/>
                         <a:cs typeface="Arial" charset="0"/>
@@ -2909,9 +2909,9 @@
                         <a:buNone/>
                       </a:pPr>
                       <a:r>
-                        <a:rPr lang="en-US" sz="800" dirty="0">
+                        <a:rPr lang="en-US" sz="700" dirty="0">
                           <a:solidFill>
-                            <a:srgbClr val="000000"/>
+                            <a:srgbClr val="808080"/>
                           </a:solidFill>
                           <a:latin typeface="Arial" pitchFamily="34" charset="0"/>
                           <a:ea typeface="Arial" pitchFamily="34" charset="-122"/>
@@ -2919,7 +2919,7 @@
                         </a:rPr>
                         <a:t>10.7</a:t>
                       </a:r>
-                      <a:endParaRPr lang="en-US" sz="800" dirty="0">
+                      <a:endParaRPr lang="en-US" sz="700" dirty="0">
                         <a:latin typeface="Arial" charset="0"/>
                         <a:ea typeface="Arial" charset="0"/>
                         <a:cs typeface="Arial" charset="0"/>
@@ -2976,7 +2976,7 @@
                       <a:r>
                         <a:rPr lang="en-US" sz="700" dirty="0">
                           <a:solidFill>
-                            <a:srgbClr val="000000"/>
+                            <a:srgbClr val="808080"/>
                           </a:solidFill>
                           <a:latin typeface="Arial" pitchFamily="34" charset="0"/>
                           <a:ea typeface="Arial" pitchFamily="34" charset="-122"/>
@@ -3159,7 +3159,7 @@
                       <a:pPr algn="ctr" indent="0" marL="0">
                         <a:buNone/>
                       </a:pPr>
-                      <a:endParaRPr lang="en-US" sz="800" dirty="0">
+                      <a:endParaRPr lang="en-US" sz="700" dirty="0">
                         <a:latin typeface="Arial" charset="0"/>
                         <a:ea typeface="Arial" charset="0"/>
                         <a:cs typeface="Arial" charset="0"/>
@@ -3214,9 +3214,9 @@
                         <a:buNone/>
                       </a:pPr>
                       <a:r>
-                        <a:rPr lang="en-US" sz="800" dirty="0">
+                        <a:rPr lang="en-US" sz="700" dirty="0">
                           <a:solidFill>
-                            <a:srgbClr val="000000"/>
+                            <a:srgbClr val="808080"/>
                           </a:solidFill>
                           <a:latin typeface="Arial" pitchFamily="34" charset="0"/>
                           <a:ea typeface="Arial" pitchFamily="34" charset="-122"/>
@@ -3224,7 +3224,7 @@
                         </a:rPr>
                         <a:t>13.2</a:t>
                       </a:r>
-                      <a:endParaRPr lang="en-US" sz="800" dirty="0">
+                      <a:endParaRPr lang="en-US" sz="700" dirty="0">
                         <a:latin typeface="Arial" charset="0"/>
                         <a:ea typeface="Arial" charset="0"/>
                         <a:cs typeface="Arial" charset="0"/>
@@ -3279,9 +3279,9 @@
                         <a:buNone/>
                       </a:pPr>
                       <a:r>
-                        <a:rPr lang="en-US" sz="800" dirty="0">
+                        <a:rPr lang="en-US" sz="700" dirty="0">
                           <a:solidFill>
-                            <a:srgbClr val="000000"/>
+                            <a:srgbClr val="808080"/>
                           </a:solidFill>
                           <a:latin typeface="Arial" pitchFamily="34" charset="0"/>
                           <a:ea typeface="Arial" pitchFamily="34" charset="-122"/>
@@ -3289,7 +3289,7 @@
                         </a:rPr>
                         <a:t>10.7</a:t>
                       </a:r>
-                      <a:endParaRPr lang="en-US" sz="800" dirty="0">
+                      <a:endParaRPr lang="en-US" sz="700" dirty="0">
                         <a:latin typeface="Arial" charset="0"/>
                         <a:ea typeface="Arial" charset="0"/>
                         <a:cs typeface="Arial" charset="0"/>
@@ -4301,61 +4301,61 @@
                       <a:pPr algn="ctr" indent="0" marL="0">
                         <a:buNone/>
                       </a:pPr>
-                      <a:endParaRPr lang="en-US" sz="800" dirty="0">
-                        <a:latin typeface="Arial" charset="0"/>
-                        <a:ea typeface="Arial" charset="0"/>
-                        <a:cs typeface="Arial" charset="0"/>
-                      </a:endParaRPr>
-                    </a:p>
-                  </a:txBody>
-                  <a:tcPr marL="91440" marR="91440" marT="45720" marB="45720">
-                    <a:lnL w="3810" cap="flat" cmpd="sng" algn="ctr">
-                      <a:solidFill>
-                        <a:srgbClr val="D0D0D0"/>
-                      </a:solidFill>
-                      <a:prstDash val="solid"/>
-                      <a:round/>
-                      <a:headEnd type="none" w="med" len="med"/>
-                      <a:tailEnd type="none" w="med" len="med"/>
-                    </a:lnL>
-                    <a:lnR w="3810" cap="flat" cmpd="sng" algn="ctr">
-                      <a:solidFill>
-                        <a:srgbClr val="D0D0D0"/>
-                      </a:solidFill>
-                      <a:prstDash val="solid"/>
-                      <a:round/>
-                      <a:headEnd type="none" w="med" len="med"/>
-                      <a:tailEnd type="none" w="med" len="med"/>
-                    </a:lnR>
-                    <a:lnT w="3810" cap="flat" cmpd="sng" algn="ctr">
-                      <a:solidFill>
-                        <a:srgbClr val="D0D0D0"/>
-                      </a:solidFill>
-                      <a:prstDash val="solid"/>
-                      <a:round/>
-                      <a:headEnd type="none" w="med" len="med"/>
-                      <a:tailEnd type="none" w="med" len="med"/>
-                    </a:lnT>
-                    <a:lnB w="3810" cap="flat" cmpd="sng" algn="ctr">
-                      <a:solidFill>
-                        <a:srgbClr val="D0D0D0"/>
-                      </a:solidFill>
-                      <a:prstDash val="solid"/>
-                      <a:round/>
-                      <a:headEnd type="none" w="med" len="med"/>
-                      <a:tailEnd type="none" w="med" len="med"/>
-                    </a:lnB>
-                  </a:tcPr>
-                </a:tc>
-                <a:tc>
-                  <a:txBody>
-                    <a:bodyPr/>
-                    <a:lstStyle/>
-                    <a:p>
-                      <a:pPr algn="ctr" indent="0" marL="0">
-                        <a:buNone/>
-                      </a:pPr>
-                      <a:endParaRPr lang="en-US" sz="800" dirty="0">
+                      <a:endParaRPr lang="en-US" sz="700" dirty="0">
+                        <a:latin typeface="Arial" charset="0"/>
+                        <a:ea typeface="Arial" charset="0"/>
+                        <a:cs typeface="Arial" charset="0"/>
+                      </a:endParaRPr>
+                    </a:p>
+                  </a:txBody>
+                  <a:tcPr marL="91440" marR="91440" marT="45720" marB="45720">
+                    <a:lnL w="3810" cap="flat" cmpd="sng" algn="ctr">
+                      <a:solidFill>
+                        <a:srgbClr val="D0D0D0"/>
+                      </a:solidFill>
+                      <a:prstDash val="solid"/>
+                      <a:round/>
+                      <a:headEnd type="none" w="med" len="med"/>
+                      <a:tailEnd type="none" w="med" len="med"/>
+                    </a:lnL>
+                    <a:lnR w="3810" cap="flat" cmpd="sng" algn="ctr">
+                      <a:solidFill>
+                        <a:srgbClr val="D0D0D0"/>
+                      </a:solidFill>
+                      <a:prstDash val="solid"/>
+                      <a:round/>
+                      <a:headEnd type="none" w="med" len="med"/>
+                      <a:tailEnd type="none" w="med" len="med"/>
+                    </a:lnR>
+                    <a:lnT w="3810" cap="flat" cmpd="sng" algn="ctr">
+                      <a:solidFill>
+                        <a:srgbClr val="D0D0D0"/>
+                      </a:solidFill>
+                      <a:prstDash val="solid"/>
+                      <a:round/>
+                      <a:headEnd type="none" w="med" len="med"/>
+                      <a:tailEnd type="none" w="med" len="med"/>
+                    </a:lnT>
+                    <a:lnB w="3810" cap="flat" cmpd="sng" algn="ctr">
+                      <a:solidFill>
+                        <a:srgbClr val="D0D0D0"/>
+                      </a:solidFill>
+                      <a:prstDash val="solid"/>
+                      <a:round/>
+                      <a:headEnd type="none" w="med" len="med"/>
+                      <a:tailEnd type="none" w="med" len="med"/>
+                    </a:lnB>
+                  </a:tcPr>
+                </a:tc>
+                <a:tc>
+                  <a:txBody>
+                    <a:bodyPr/>
+                    <a:lstStyle/>
+                    <a:p>
+                      <a:pPr algn="ctr" indent="0" marL="0">
+                        <a:buNone/>
+                      </a:pPr>
+                      <a:endParaRPr lang="en-US" sz="700" dirty="0">
                         <a:latin typeface="Arial" charset="0"/>
                         <a:ea typeface="Arial" charset="0"/>
                         <a:cs typeface="Arial" charset="0"/>
@@ -4563,7 +4563,7 @@
                 <a:ea typeface="Arial" pitchFamily="34" charset="-122"/>
                 <a:cs typeface="Arial" pitchFamily="34" charset="-120"/>
               </a:rPr>
-              <a:t>• Urban hit 9.7D in March — below 10D target for first time
+              <a:t>• Urban hit 9.7D in March — below 10D target
 </a:t>
             </a:r>
             <a:pPr indent="0" marL="0">
@@ -4578,7 +4578,7 @@
                 <a:ea typeface="Arial" pitchFamily="34" charset="-122"/>
                 <a:cs typeface="Arial" pitchFamily="34" charset="-120"/>
               </a:rPr>
-              <a:t>• Brown at 9.3D — strongest ASM. Graham at 10.0D — nearly there
+              <a:t>• Brown at 9.3D — strongest ASM. Graham at 10.0D
 </a:t>
             </a:r>
             <a:pPr indent="0" marL="0">
@@ -4608,7 +4608,7 @@
                 <a:ea typeface="Arial" pitchFamily="34" charset="-122"/>
                 <a:cs typeface="Arial" pitchFamily="34" charset="-120"/>
               </a:rPr>
-              <a:t>• 7 ASCs stabilized by our team and handed off to new managers
+              <a:t>• 7 ASCs stabilized and handed off to new managers
 </a:t>
             </a:r>
             <a:pPr indent="0" marL="0">
@@ -4639,7 +4639,7 @@
         <p:spPr>
           <a:xfrm>
             <a:off x="7772400" y="1234440"/>
-            <a:ext cx="3749040" cy="228600"/>
+            <a:ext cx="4114800" cy="228600"/>
           </a:xfrm>
           <a:prstGeom prst="rect">
             <a:avLst/>
@@ -4659,7 +4659,7 @@
         <p:spPr>
           <a:xfrm>
             <a:off x="7772400" y="1234440"/>
-            <a:ext cx="3749040" cy="228600"/>
+            <a:ext cx="4114800" cy="228600"/>
           </a:xfrm>
           <a:prstGeom prst="rect">
             <a:avLst/>
@@ -4698,7 +4698,7 @@
         <p:spPr>
           <a:xfrm>
             <a:off x="7863840" y="1508760"/>
-            <a:ext cx="3566160" cy="1645920"/>
+            <a:ext cx="3931920" cy="1645920"/>
           </a:xfrm>
           <a:prstGeom prst="rect">
             <a:avLst/>
@@ -4722,7 +4722,7 @@
                 <a:ea typeface="Arial" pitchFamily="34" charset="-122"/>
                 <a:cs typeface="Arial" pitchFamily="34" charset="-120"/>
               </a:rPr>
-              <a:t>• Continue REPAIR framework — monthly reviews per focus ASC
+              <a:t>• REPAIR framework — monthly reviews per focus ASC
 </a:t>
             </a:r>
             <a:pPr indent="0" marL="0">
@@ -4737,7 +4737,7 @@
                 <a:ea typeface="Arial" pitchFamily="34" charset="-122"/>
                 <a:cs typeface="Arial" pitchFamily="34" charset="-120"/>
               </a:rPr>
-              <a:t>• Selecting 5 new focus ASCs to replace handed-off accounts
+              <a:t>• Selecting 5 new focus ASCs replacing handed-off accounts
 </a:t>
             </a:r>
             <a:pPr indent="0" marL="0">
@@ -4752,7 +4752,7 @@
                 <a:ea typeface="Arial" pitchFamily="34" charset="-122"/>
                 <a:cs typeface="Arial" pitchFamily="34" charset="-120"/>
               </a:rPr>
-              <a:t>• Immediate engagement: A+ Appliance (+11.3D), Doctor Maint (+10.7D)
+              <a:t>• Engage: A+ Appliance (+11.3D), Doctor Maint (+10.7D)
 </a:t>
             </a:r>
             <a:pPr indent="0" marL="0">
@@ -4767,7 +4767,7 @@
                 <a:ea typeface="Arial" pitchFamily="34" charset="-122"/>
                 <a:cs typeface="Arial" pitchFamily="34" charset="-120"/>
               </a:rPr>
-              <a:t>• Redirect volume from non-improving ASCs to proven partners
+              <a:t>• Redirect volume from non-improving to proven partners
 </a:t>
             </a:r>
             <a:pPr indent="0" marL="0">
@@ -4857,7 +4857,7 @@
         <p:spPr>
           <a:xfrm>
             <a:off x="3566160" y="3858768"/>
-            <a:ext cx="3566160" cy="1371600"/>
+            <a:ext cx="3566160" cy="1188720"/>
           </a:xfrm>
           <a:prstGeom prst="rect">
             <a:avLst/>
@@ -4896,7 +4896,7 @@
                 <a:ea typeface="Arial" pitchFamily="34" charset="-122"/>
                 <a:cs typeface="Arial" pitchFamily="34" charset="-120"/>
               </a:rPr>
-              <a:t>• Graham: 272 jobs (11.7D avg) — Brown: 216 jobs (9.2D avg)
+              <a:t>• Graham: 272 (11.7D avg) | Brown: 216 (9.2D avg)
 </a:t>
             </a:r>
             <a:pPr indent="0" marL="0">
@@ -4911,7 +4911,7 @@
                 <a:ea typeface="Arial" pitchFamily="34" charset="-122"/>
                 <a:cs typeface="Arial" pitchFamily="34" charset="-120"/>
               </a:rPr>
-              <a:t>• Parts ordered: 97 jobs | Waiting visit: 79 | Reschedule: 59
+              <a:t>• Top: Parts ordered (97), Waiting visit (79), Reschedule (59)
 </a:t>
             </a:r>
             <a:pPr indent="0" marL="0">
@@ -4942,7 +4942,7 @@
         <p:spPr>
           <a:xfrm>
             <a:off x="7772400" y="3584448"/>
-            <a:ext cx="3749040" cy="228600"/>
+            <a:ext cx="4114800" cy="228600"/>
           </a:xfrm>
           <a:prstGeom prst="rect">
             <a:avLst/>
@@ -4962,7 +4962,7 @@
         <p:spPr>
           <a:xfrm>
             <a:off x="7772400" y="3584448"/>
-            <a:ext cx="3749040" cy="228600"/>
+            <a:ext cx="4114800" cy="228600"/>
           </a:xfrm>
           <a:prstGeom prst="rect">
             <a:avLst/>
@@ -5001,7 +5001,7 @@
         <p:spPr>
           <a:xfrm>
             <a:off x="7863840" y="3858768"/>
-            <a:ext cx="3566160" cy="1371600"/>
+            <a:ext cx="3931920" cy="1188720"/>
           </a:xfrm>
           <a:prstGeom prst="rect">
             <a:avLst/>
@@ -5124,7 +5124,7 @@
                 <a:ea typeface="Arial" pitchFamily="34" charset="-122"/>
                 <a:cs typeface="Arial" pitchFamily="34" charset="-120"/>
               </a:rPr>
-              <a:t>Splice 26.3→9.8D | Consumers Mobile 17.4→6.4D | J&amp;J 20.5→8.0D | DESIJA 16.9→8.9D | Lifetime 21.4→6.0D | Sams 12.4→9.4D | Disaster 16.7→10.0D</a:t>
+              <a:t>Splice 26.3&gt;9.8D | Consumers Mobile 17.4&gt;6.4D | J&amp;J 20.5&gt;8.0D | DESIJA 16.9&gt;8.9D | Lifetime 21.4&gt;6.0D | Sams 12.4&gt;9.4D | Disaster 16.7&gt;10.0D</a:t>
             </a:r>
             <a:endParaRPr lang="en-US" sz="700" dirty="0"/>
           </a:p>
@@ -5409,7 +5409,7 @@
         </p:nvGraphicFramePr>
         <p:xfrm>
           <a:off x="182880" y="1335024"/>
-          <a:ext cx="3291840" cy="914400"/>
+          <a:ext cx="2971800" cy="914400"/>
         </p:xfrm>
         <a:graphic>
           <a:graphicData uri="http://schemas.openxmlformats.org/drawingml/2006/table">
@@ -5417,11 +5417,11 @@
               <a:tblPr/>
               <a:tblGrid>
                 <a:gridCol w="45720"/>
-                <a:gridCol w="1005840"/>
+                <a:gridCol w="960120"/>
                 <a:gridCol w="457200"/>
                 <a:gridCol w="457200"/>
                 <a:gridCol w="457200"/>
-                <a:gridCol w="548640"/>
+                <a:gridCol w="594360"/>
               </a:tblGrid>
               <a:tr h="228600">
                 <a:tc>
@@ -6550,7 +6550,7 @@
                           <a:ea typeface="Arial" pitchFamily="34" charset="-122"/>
                           <a:cs typeface="Arial" pitchFamily="34" charset="-120"/>
                         </a:rPr>
-                        <a:t>Rural Combined</a:t>
+                        <a:t>Rural</a:t>
                       </a:r>
                       <a:endParaRPr lang="en-US" sz="800" dirty="0">
                         <a:latin typeface="Arial" charset="0"/>
@@ -6987,7 +6987,7 @@
                       <a:pPr algn="ctr" indent="0" marL="0">
                         <a:buNone/>
                       </a:pPr>
-                      <a:endParaRPr lang="en-US" sz="800" dirty="0">
+                      <a:endParaRPr lang="en-US" sz="700" dirty="0">
                         <a:latin typeface="Arial" charset="0"/>
                         <a:ea typeface="Arial" charset="0"/>
                         <a:cs typeface="Arial" charset="0"/>
@@ -7042,9 +7042,9 @@
                         <a:buNone/>
                       </a:pPr>
                       <a:r>
-                        <a:rPr lang="en-US" sz="800" dirty="0">
+                        <a:rPr lang="en-US" sz="700" dirty="0">
                           <a:solidFill>
-                            <a:srgbClr val="000000"/>
+                            <a:srgbClr val="808080"/>
                           </a:solidFill>
                           <a:latin typeface="Arial" pitchFamily="34" charset="0"/>
                           <a:ea typeface="Arial" pitchFamily="34" charset="-122"/>
@@ -7052,7 +7052,7 @@
                         </a:rPr>
                         <a:t>14.0</a:t>
                       </a:r>
-                      <a:endParaRPr lang="en-US" sz="800" dirty="0">
+                      <a:endParaRPr lang="en-US" sz="700" dirty="0">
                         <a:latin typeface="Arial" charset="0"/>
                         <a:ea typeface="Arial" charset="0"/>
                         <a:cs typeface="Arial" charset="0"/>
@@ -7107,9 +7107,9 @@
                         <a:buNone/>
                       </a:pPr>
                       <a:r>
-                        <a:rPr lang="en-US" sz="800" dirty="0">
+                        <a:rPr lang="en-US" sz="700" dirty="0">
                           <a:solidFill>
-                            <a:srgbClr val="000000"/>
+                            <a:srgbClr val="808080"/>
                           </a:solidFill>
                           <a:latin typeface="Arial" pitchFamily="34" charset="0"/>
                           <a:ea typeface="Arial" pitchFamily="34" charset="-122"/>
@@ -7117,7 +7117,7 @@
                         </a:rPr>
                         <a:t>13.0</a:t>
                       </a:r>
-                      <a:endParaRPr lang="en-US" sz="800" dirty="0">
+                      <a:endParaRPr lang="en-US" sz="700" dirty="0">
                         <a:latin typeface="Arial" charset="0"/>
                         <a:ea typeface="Arial" charset="0"/>
                         <a:cs typeface="Arial" charset="0"/>
@@ -7174,7 +7174,7 @@
                       <a:r>
                         <a:rPr lang="en-US" sz="700" dirty="0">
                           <a:solidFill>
-                            <a:srgbClr val="000000"/>
+                            <a:srgbClr val="808080"/>
                           </a:solidFill>
                           <a:latin typeface="Arial" pitchFamily="34" charset="0"/>
                           <a:ea typeface="Arial" pitchFamily="34" charset="-122"/>
@@ -7357,7 +7357,7 @@
                       <a:pPr algn="ctr" indent="0" marL="0">
                         <a:buNone/>
                       </a:pPr>
-                      <a:endParaRPr lang="en-US" sz="800" dirty="0">
+                      <a:endParaRPr lang="en-US" sz="700" dirty="0">
                         <a:latin typeface="Arial" charset="0"/>
                         <a:ea typeface="Arial" charset="0"/>
                         <a:cs typeface="Arial" charset="0"/>
@@ -7412,9 +7412,9 @@
                         <a:buNone/>
                       </a:pPr>
                       <a:r>
-                        <a:rPr lang="en-US" sz="800" dirty="0">
+                        <a:rPr lang="en-US" sz="700" dirty="0">
                           <a:solidFill>
-                            <a:srgbClr val="000000"/>
+                            <a:srgbClr val="808080"/>
                           </a:solidFill>
                           <a:latin typeface="Arial" pitchFamily="34" charset="0"/>
                           <a:ea typeface="Arial" pitchFamily="34" charset="-122"/>
@@ -7422,7 +7422,7 @@
                         </a:rPr>
                         <a:t>13.2</a:t>
                       </a:r>
-                      <a:endParaRPr lang="en-US" sz="800" dirty="0">
+                      <a:endParaRPr lang="en-US" sz="700" dirty="0">
                         <a:latin typeface="Arial" charset="0"/>
                         <a:ea typeface="Arial" charset="0"/>
                         <a:cs typeface="Arial" charset="0"/>
@@ -7477,9 +7477,9 @@
                         <a:buNone/>
                       </a:pPr>
                       <a:r>
-                        <a:rPr lang="en-US" sz="800" dirty="0">
+                        <a:rPr lang="en-US" sz="700" dirty="0">
                           <a:solidFill>
-                            <a:srgbClr val="000000"/>
+                            <a:srgbClr val="808080"/>
                           </a:solidFill>
                           <a:latin typeface="Arial" pitchFamily="34" charset="0"/>
                           <a:ea typeface="Arial" pitchFamily="34" charset="-122"/>
@@ -7487,7 +7487,7 @@
                         </a:rPr>
                         <a:t>13.6</a:t>
                       </a:r>
-                      <a:endParaRPr lang="en-US" sz="800" dirty="0">
+                      <a:endParaRPr lang="en-US" sz="700" dirty="0">
                         <a:latin typeface="Arial" charset="0"/>
                         <a:ea typeface="Arial" charset="0"/>
                         <a:cs typeface="Arial" charset="0"/>
@@ -7544,7 +7544,7 @@
                       <a:r>
                         <a:rPr lang="en-US" sz="700" dirty="0">
                           <a:solidFill>
-                            <a:srgbClr val="000000"/>
+                            <a:srgbClr val="808080"/>
                           </a:solidFill>
                           <a:latin typeface="Arial" pitchFamily="34" charset="0"/>
                           <a:ea typeface="Arial" pitchFamily="34" charset="-122"/>
@@ -8434,115 +8434,115 @@
                       <a:pPr algn="ctr" indent="0" marL="0">
                         <a:buNone/>
                       </a:pPr>
-                      <a:endParaRPr lang="en-US" sz="800" dirty="0">
-                        <a:latin typeface="Arial" charset="0"/>
-                        <a:ea typeface="Arial" charset="0"/>
-                        <a:cs typeface="Arial" charset="0"/>
-                      </a:endParaRPr>
-                    </a:p>
-                  </a:txBody>
-                  <a:tcPr marL="91440" marR="91440" marT="45720" marB="45720">
-                    <a:lnL w="3810" cap="flat" cmpd="sng" algn="ctr">
-                      <a:solidFill>
-                        <a:srgbClr val="D0D0D0"/>
-                      </a:solidFill>
-                      <a:prstDash val="solid"/>
-                      <a:round/>
-                      <a:headEnd type="none" w="med" len="med"/>
-                      <a:tailEnd type="none" w="med" len="med"/>
-                    </a:lnL>
-                    <a:lnR w="3810" cap="flat" cmpd="sng" algn="ctr">
-                      <a:solidFill>
-                        <a:srgbClr val="D0D0D0"/>
-                      </a:solidFill>
-                      <a:prstDash val="solid"/>
-                      <a:round/>
-                      <a:headEnd type="none" w="med" len="med"/>
-                      <a:tailEnd type="none" w="med" len="med"/>
-                    </a:lnR>
-                    <a:lnT w="3810" cap="flat" cmpd="sng" algn="ctr">
-                      <a:solidFill>
-                        <a:srgbClr val="D0D0D0"/>
-                      </a:solidFill>
-                      <a:prstDash val="solid"/>
-                      <a:round/>
-                      <a:headEnd type="none" w="med" len="med"/>
-                      <a:tailEnd type="none" w="med" len="med"/>
-                    </a:lnT>
-                    <a:lnB w="3810" cap="flat" cmpd="sng" algn="ctr">
-                      <a:solidFill>
-                        <a:srgbClr val="D0D0D0"/>
-                      </a:solidFill>
-                      <a:prstDash val="solid"/>
-                      <a:round/>
-                      <a:headEnd type="none" w="med" len="med"/>
-                      <a:tailEnd type="none" w="med" len="med"/>
-                    </a:lnB>
-                  </a:tcPr>
-                </a:tc>
-                <a:tc>
-                  <a:txBody>
-                    <a:bodyPr/>
-                    <a:lstStyle/>
-                    <a:p>
-                      <a:pPr algn="ctr" indent="0" marL="0">
-                        <a:buNone/>
-                      </a:pPr>
-                      <a:endParaRPr lang="en-US" sz="800" dirty="0">
-                        <a:latin typeface="Arial" charset="0"/>
-                        <a:ea typeface="Arial" charset="0"/>
-                        <a:cs typeface="Arial" charset="0"/>
-                      </a:endParaRPr>
-                    </a:p>
-                  </a:txBody>
-                  <a:tcPr marL="91440" marR="91440" marT="45720" marB="45720">
-                    <a:lnL w="3810" cap="flat" cmpd="sng" algn="ctr">
-                      <a:solidFill>
-                        <a:srgbClr val="D0D0D0"/>
-                      </a:solidFill>
-                      <a:prstDash val="solid"/>
-                      <a:round/>
-                      <a:headEnd type="none" w="med" len="med"/>
-                      <a:tailEnd type="none" w="med" len="med"/>
-                    </a:lnL>
-                    <a:lnR w="3810" cap="flat" cmpd="sng" algn="ctr">
-                      <a:solidFill>
-                        <a:srgbClr val="D0D0D0"/>
-                      </a:solidFill>
-                      <a:prstDash val="solid"/>
-                      <a:round/>
-                      <a:headEnd type="none" w="med" len="med"/>
-                      <a:tailEnd type="none" w="med" len="med"/>
-                    </a:lnR>
-                    <a:lnT w="3810" cap="flat" cmpd="sng" algn="ctr">
-                      <a:solidFill>
-                        <a:srgbClr val="D0D0D0"/>
-                      </a:solidFill>
-                      <a:prstDash val="solid"/>
-                      <a:round/>
-                      <a:headEnd type="none" w="med" len="med"/>
-                      <a:tailEnd type="none" w="med" len="med"/>
-                    </a:lnT>
-                    <a:lnB w="3810" cap="flat" cmpd="sng" algn="ctr">
-                      <a:solidFill>
-                        <a:srgbClr val="D0D0D0"/>
-                      </a:solidFill>
-                      <a:prstDash val="solid"/>
-                      <a:round/>
-                      <a:headEnd type="none" w="med" len="med"/>
-                      <a:tailEnd type="none" w="med" len="med"/>
-                    </a:lnB>
-                  </a:tcPr>
-                </a:tc>
-                <a:tc>
-                  <a:txBody>
-                    <a:bodyPr/>
-                    <a:lstStyle/>
-                    <a:p>
-                      <a:pPr algn="ctr" indent="0" marL="0">
-                        <a:buNone/>
-                      </a:pPr>
-                      <a:endParaRPr lang="en-US" sz="800" dirty="0">
+                      <a:endParaRPr lang="en-US" sz="700" dirty="0">
+                        <a:latin typeface="Arial" charset="0"/>
+                        <a:ea typeface="Arial" charset="0"/>
+                        <a:cs typeface="Arial" charset="0"/>
+                      </a:endParaRPr>
+                    </a:p>
+                  </a:txBody>
+                  <a:tcPr marL="91440" marR="91440" marT="45720" marB="45720">
+                    <a:lnL w="3810" cap="flat" cmpd="sng" algn="ctr">
+                      <a:solidFill>
+                        <a:srgbClr val="D0D0D0"/>
+                      </a:solidFill>
+                      <a:prstDash val="solid"/>
+                      <a:round/>
+                      <a:headEnd type="none" w="med" len="med"/>
+                      <a:tailEnd type="none" w="med" len="med"/>
+                    </a:lnL>
+                    <a:lnR w="3810" cap="flat" cmpd="sng" algn="ctr">
+                      <a:solidFill>
+                        <a:srgbClr val="D0D0D0"/>
+                      </a:solidFill>
+                      <a:prstDash val="solid"/>
+                      <a:round/>
+                      <a:headEnd type="none" w="med" len="med"/>
+                      <a:tailEnd type="none" w="med" len="med"/>
+                    </a:lnR>
+                    <a:lnT w="3810" cap="flat" cmpd="sng" algn="ctr">
+                      <a:solidFill>
+                        <a:srgbClr val="D0D0D0"/>
+                      </a:solidFill>
+                      <a:prstDash val="solid"/>
+                      <a:round/>
+                      <a:headEnd type="none" w="med" len="med"/>
+                      <a:tailEnd type="none" w="med" len="med"/>
+                    </a:lnT>
+                    <a:lnB w="3810" cap="flat" cmpd="sng" algn="ctr">
+                      <a:solidFill>
+                        <a:srgbClr val="D0D0D0"/>
+                      </a:solidFill>
+                      <a:prstDash val="solid"/>
+                      <a:round/>
+                      <a:headEnd type="none" w="med" len="med"/>
+                      <a:tailEnd type="none" w="med" len="med"/>
+                    </a:lnB>
+                  </a:tcPr>
+                </a:tc>
+                <a:tc>
+                  <a:txBody>
+                    <a:bodyPr/>
+                    <a:lstStyle/>
+                    <a:p>
+                      <a:pPr algn="ctr" indent="0" marL="0">
+                        <a:buNone/>
+                      </a:pPr>
+                      <a:endParaRPr lang="en-US" sz="700" dirty="0">
+                        <a:latin typeface="Arial" charset="0"/>
+                        <a:ea typeface="Arial" charset="0"/>
+                        <a:cs typeface="Arial" charset="0"/>
+                      </a:endParaRPr>
+                    </a:p>
+                  </a:txBody>
+                  <a:tcPr marL="91440" marR="91440" marT="45720" marB="45720">
+                    <a:lnL w="3810" cap="flat" cmpd="sng" algn="ctr">
+                      <a:solidFill>
+                        <a:srgbClr val="D0D0D0"/>
+                      </a:solidFill>
+                      <a:prstDash val="solid"/>
+                      <a:round/>
+                      <a:headEnd type="none" w="med" len="med"/>
+                      <a:tailEnd type="none" w="med" len="med"/>
+                    </a:lnL>
+                    <a:lnR w="3810" cap="flat" cmpd="sng" algn="ctr">
+                      <a:solidFill>
+                        <a:srgbClr val="D0D0D0"/>
+                      </a:solidFill>
+                      <a:prstDash val="solid"/>
+                      <a:round/>
+                      <a:headEnd type="none" w="med" len="med"/>
+                      <a:tailEnd type="none" w="med" len="med"/>
+                    </a:lnR>
+                    <a:lnT w="3810" cap="flat" cmpd="sng" algn="ctr">
+                      <a:solidFill>
+                        <a:srgbClr val="D0D0D0"/>
+                      </a:solidFill>
+                      <a:prstDash val="solid"/>
+                      <a:round/>
+                      <a:headEnd type="none" w="med" len="med"/>
+                      <a:tailEnd type="none" w="med" len="med"/>
+                    </a:lnT>
+                    <a:lnB w="3810" cap="flat" cmpd="sng" algn="ctr">
+                      <a:solidFill>
+                        <a:srgbClr val="D0D0D0"/>
+                      </a:solidFill>
+                      <a:prstDash val="solid"/>
+                      <a:round/>
+                      <a:headEnd type="none" w="med" len="med"/>
+                      <a:tailEnd type="none" w="med" len="med"/>
+                    </a:lnB>
+                  </a:tcPr>
+                </a:tc>
+                <a:tc>
+                  <a:txBody>
+                    <a:bodyPr/>
+                    <a:lstStyle/>
+                    <a:p>
+                      <a:pPr algn="ctr" indent="0" marL="0">
+                        <a:buNone/>
+                      </a:pPr>
+                      <a:endParaRPr lang="en-US" sz="700" dirty="0">
                         <a:latin typeface="Arial" charset="0"/>
                         <a:ea typeface="Arial" charset="0"/>
                         <a:cs typeface="Arial" charset="0"/>
@@ -8605,7 +8605,7 @@
                           <a:ea typeface="Arial" pitchFamily="34" charset="-122"/>
                           <a:cs typeface="Arial" pitchFamily="34" charset="-120"/>
                         </a:rPr>
-                        <a:t>11.9 ↓</a:t>
+                        <a:t>11.9</a:t>
                       </a:r>
                       <a:endParaRPr lang="en-US" sz="700" dirty="0">
                         <a:latin typeface="Arial" charset="0"/>
@@ -8782,115 +8782,115 @@
                       <a:pPr algn="ctr" indent="0" marL="0">
                         <a:buNone/>
                       </a:pPr>
-                      <a:endParaRPr lang="en-US" sz="800" dirty="0">
-                        <a:latin typeface="Arial" charset="0"/>
-                        <a:ea typeface="Arial" charset="0"/>
-                        <a:cs typeface="Arial" charset="0"/>
-                      </a:endParaRPr>
-                    </a:p>
-                  </a:txBody>
-                  <a:tcPr marL="91440" marR="91440" marT="45720" marB="45720">
-                    <a:lnL w="3810" cap="flat" cmpd="sng" algn="ctr">
-                      <a:solidFill>
-                        <a:srgbClr val="D0D0D0"/>
-                      </a:solidFill>
-                      <a:prstDash val="solid"/>
-                      <a:round/>
-                      <a:headEnd type="none" w="med" len="med"/>
-                      <a:tailEnd type="none" w="med" len="med"/>
-                    </a:lnL>
-                    <a:lnR w="3810" cap="flat" cmpd="sng" algn="ctr">
-                      <a:solidFill>
-                        <a:srgbClr val="D0D0D0"/>
-                      </a:solidFill>
-                      <a:prstDash val="solid"/>
-                      <a:round/>
-                      <a:headEnd type="none" w="med" len="med"/>
-                      <a:tailEnd type="none" w="med" len="med"/>
-                    </a:lnR>
-                    <a:lnT w="3810" cap="flat" cmpd="sng" algn="ctr">
-                      <a:solidFill>
-                        <a:srgbClr val="D0D0D0"/>
-                      </a:solidFill>
-                      <a:prstDash val="solid"/>
-                      <a:round/>
-                      <a:headEnd type="none" w="med" len="med"/>
-                      <a:tailEnd type="none" w="med" len="med"/>
-                    </a:lnT>
-                    <a:lnB w="3810" cap="flat" cmpd="sng" algn="ctr">
-                      <a:solidFill>
-                        <a:srgbClr val="D0D0D0"/>
-                      </a:solidFill>
-                      <a:prstDash val="solid"/>
-                      <a:round/>
-                      <a:headEnd type="none" w="med" len="med"/>
-                      <a:tailEnd type="none" w="med" len="med"/>
-                    </a:lnB>
-                  </a:tcPr>
-                </a:tc>
-                <a:tc>
-                  <a:txBody>
-                    <a:bodyPr/>
-                    <a:lstStyle/>
-                    <a:p>
-                      <a:pPr algn="ctr" indent="0" marL="0">
-                        <a:buNone/>
-                      </a:pPr>
-                      <a:endParaRPr lang="en-US" sz="800" dirty="0">
-                        <a:latin typeface="Arial" charset="0"/>
-                        <a:ea typeface="Arial" charset="0"/>
-                        <a:cs typeface="Arial" charset="0"/>
-                      </a:endParaRPr>
-                    </a:p>
-                  </a:txBody>
-                  <a:tcPr marL="91440" marR="91440" marT="45720" marB="45720">
-                    <a:lnL w="3810" cap="flat" cmpd="sng" algn="ctr">
-                      <a:solidFill>
-                        <a:srgbClr val="D0D0D0"/>
-                      </a:solidFill>
-                      <a:prstDash val="solid"/>
-                      <a:round/>
-                      <a:headEnd type="none" w="med" len="med"/>
-                      <a:tailEnd type="none" w="med" len="med"/>
-                    </a:lnL>
-                    <a:lnR w="3810" cap="flat" cmpd="sng" algn="ctr">
-                      <a:solidFill>
-                        <a:srgbClr val="D0D0D0"/>
-                      </a:solidFill>
-                      <a:prstDash val="solid"/>
-                      <a:round/>
-                      <a:headEnd type="none" w="med" len="med"/>
-                      <a:tailEnd type="none" w="med" len="med"/>
-                    </a:lnR>
-                    <a:lnT w="3810" cap="flat" cmpd="sng" algn="ctr">
-                      <a:solidFill>
-                        <a:srgbClr val="D0D0D0"/>
-                      </a:solidFill>
-                      <a:prstDash val="solid"/>
-                      <a:round/>
-                      <a:headEnd type="none" w="med" len="med"/>
-                      <a:tailEnd type="none" w="med" len="med"/>
-                    </a:lnT>
-                    <a:lnB w="3810" cap="flat" cmpd="sng" algn="ctr">
-                      <a:solidFill>
-                        <a:srgbClr val="D0D0D0"/>
-                      </a:solidFill>
-                      <a:prstDash val="solid"/>
-                      <a:round/>
-                      <a:headEnd type="none" w="med" len="med"/>
-                      <a:tailEnd type="none" w="med" len="med"/>
-                    </a:lnB>
-                  </a:tcPr>
-                </a:tc>
-                <a:tc>
-                  <a:txBody>
-                    <a:bodyPr/>
-                    <a:lstStyle/>
-                    <a:p>
-                      <a:pPr algn="ctr" indent="0" marL="0">
-                        <a:buNone/>
-                      </a:pPr>
-                      <a:endParaRPr lang="en-US" sz="800" dirty="0">
+                      <a:endParaRPr lang="en-US" sz="700" dirty="0">
+                        <a:latin typeface="Arial" charset="0"/>
+                        <a:ea typeface="Arial" charset="0"/>
+                        <a:cs typeface="Arial" charset="0"/>
+                      </a:endParaRPr>
+                    </a:p>
+                  </a:txBody>
+                  <a:tcPr marL="91440" marR="91440" marT="45720" marB="45720">
+                    <a:lnL w="3810" cap="flat" cmpd="sng" algn="ctr">
+                      <a:solidFill>
+                        <a:srgbClr val="D0D0D0"/>
+                      </a:solidFill>
+                      <a:prstDash val="solid"/>
+                      <a:round/>
+                      <a:headEnd type="none" w="med" len="med"/>
+                      <a:tailEnd type="none" w="med" len="med"/>
+                    </a:lnL>
+                    <a:lnR w="3810" cap="flat" cmpd="sng" algn="ctr">
+                      <a:solidFill>
+                        <a:srgbClr val="D0D0D0"/>
+                      </a:solidFill>
+                      <a:prstDash val="solid"/>
+                      <a:round/>
+                      <a:headEnd type="none" w="med" len="med"/>
+                      <a:tailEnd type="none" w="med" len="med"/>
+                    </a:lnR>
+                    <a:lnT w="3810" cap="flat" cmpd="sng" algn="ctr">
+                      <a:solidFill>
+                        <a:srgbClr val="D0D0D0"/>
+                      </a:solidFill>
+                      <a:prstDash val="solid"/>
+                      <a:round/>
+                      <a:headEnd type="none" w="med" len="med"/>
+                      <a:tailEnd type="none" w="med" len="med"/>
+                    </a:lnT>
+                    <a:lnB w="3810" cap="flat" cmpd="sng" algn="ctr">
+                      <a:solidFill>
+                        <a:srgbClr val="D0D0D0"/>
+                      </a:solidFill>
+                      <a:prstDash val="solid"/>
+                      <a:round/>
+                      <a:headEnd type="none" w="med" len="med"/>
+                      <a:tailEnd type="none" w="med" len="med"/>
+                    </a:lnB>
+                  </a:tcPr>
+                </a:tc>
+                <a:tc>
+                  <a:txBody>
+                    <a:bodyPr/>
+                    <a:lstStyle/>
+                    <a:p>
+                      <a:pPr algn="ctr" indent="0" marL="0">
+                        <a:buNone/>
+                      </a:pPr>
+                      <a:endParaRPr lang="en-US" sz="700" dirty="0">
+                        <a:latin typeface="Arial" charset="0"/>
+                        <a:ea typeface="Arial" charset="0"/>
+                        <a:cs typeface="Arial" charset="0"/>
+                      </a:endParaRPr>
+                    </a:p>
+                  </a:txBody>
+                  <a:tcPr marL="91440" marR="91440" marT="45720" marB="45720">
+                    <a:lnL w="3810" cap="flat" cmpd="sng" algn="ctr">
+                      <a:solidFill>
+                        <a:srgbClr val="D0D0D0"/>
+                      </a:solidFill>
+                      <a:prstDash val="solid"/>
+                      <a:round/>
+                      <a:headEnd type="none" w="med" len="med"/>
+                      <a:tailEnd type="none" w="med" len="med"/>
+                    </a:lnL>
+                    <a:lnR w="3810" cap="flat" cmpd="sng" algn="ctr">
+                      <a:solidFill>
+                        <a:srgbClr val="D0D0D0"/>
+                      </a:solidFill>
+                      <a:prstDash val="solid"/>
+                      <a:round/>
+                      <a:headEnd type="none" w="med" len="med"/>
+                      <a:tailEnd type="none" w="med" len="med"/>
+                    </a:lnR>
+                    <a:lnT w="3810" cap="flat" cmpd="sng" algn="ctr">
+                      <a:solidFill>
+                        <a:srgbClr val="D0D0D0"/>
+                      </a:solidFill>
+                      <a:prstDash val="solid"/>
+                      <a:round/>
+                      <a:headEnd type="none" w="med" len="med"/>
+                      <a:tailEnd type="none" w="med" len="med"/>
+                    </a:lnT>
+                    <a:lnB w="3810" cap="flat" cmpd="sng" algn="ctr">
+                      <a:solidFill>
+                        <a:srgbClr val="D0D0D0"/>
+                      </a:solidFill>
+                      <a:prstDash val="solid"/>
+                      <a:round/>
+                      <a:headEnd type="none" w="med" len="med"/>
+                      <a:tailEnd type="none" w="med" len="med"/>
+                    </a:lnB>
+                  </a:tcPr>
+                </a:tc>
+                <a:tc>
+                  <a:txBody>
+                    <a:bodyPr/>
+                    <a:lstStyle/>
+                    <a:p>
+                      <a:pPr algn="ctr" indent="0" marL="0">
+                        <a:buNone/>
+                      </a:pPr>
+                      <a:endParaRPr lang="en-US" sz="700" dirty="0">
                         <a:latin typeface="Arial" charset="0"/>
                         <a:ea typeface="Arial" charset="0"/>
                         <a:cs typeface="Arial" charset="0"/>
@@ -9098,7 +9098,7 @@
                 <a:ea typeface="Arial" pitchFamily="34" charset="-122"/>
                 <a:cs typeface="Arial" pitchFamily="34" charset="-120"/>
               </a:rPr>
-              <a:t>• Rural still above 10D — 12.8D in March, 11.9D last 4 weeks
+              <a:t>• Rural still above 10D — 12.8D in March
 </a:t>
             </a:r>
             <a:pPr indent="0" marL="0">
@@ -9113,7 +9113,7 @@
                 <a:ea typeface="Arial" pitchFamily="34" charset="-122"/>
                 <a:cs typeface="Arial" pitchFamily="34" charset="-120"/>
               </a:rPr>
-              <a:t>• April trending 11.4D — trajectory is right
+              <a:t>• April trending 11.4D — trajectory improving
 </a:t>
             </a:r>
             <a:pPr indent="0" marL="0">
@@ -9143,7 +9143,7 @@
                 <a:ea typeface="Arial" pitchFamily="34" charset="-122"/>
                 <a:cs typeface="Arial" pitchFamily="34" charset="-120"/>
               </a:rPr>
-              <a:t>• A-OK Appliance: #1 drag, down from 25.8D to 21.4D
+              <a:t>• A-OK Appliance: #1 drag, 25.8D down to 21.4D
 </a:t>
             </a:r>
             <a:pPr indent="0" marL="0">
@@ -9174,7 +9174,7 @@
         <p:spPr>
           <a:xfrm>
             <a:off x="7772400" y="1234440"/>
-            <a:ext cx="3749040" cy="228600"/>
+            <a:ext cx="4114800" cy="228600"/>
           </a:xfrm>
           <a:prstGeom prst="rect">
             <a:avLst/>
@@ -9194,7 +9194,7 @@
         <p:spPr>
           <a:xfrm>
             <a:off x="7772400" y="1234440"/>
-            <a:ext cx="3749040" cy="228600"/>
+            <a:ext cx="4114800" cy="228600"/>
           </a:xfrm>
           <a:prstGeom prst="rect">
             <a:avLst/>
@@ -9233,7 +9233,7 @@
         <p:spPr>
           <a:xfrm>
             <a:off x="7863840" y="1508760"/>
-            <a:ext cx="3566160" cy="1645920"/>
+            <a:ext cx="3931920" cy="1645920"/>
           </a:xfrm>
           <a:prstGeom prst="rect">
             <a:avLst/>
@@ -9272,7 +9272,7 @@
                 <a:ea typeface="Arial" pitchFamily="34" charset="-122"/>
                 <a:cs typeface="Arial" pitchFamily="34" charset="-120"/>
               </a:rPr>
-              <a:t>• Keisers reversed 17.9→30.9D — intervention required
+              <a:t>• Keisers reversed 17.9&gt;30.9D — intervention required
 </a:t>
             </a:r>
             <a:pPr indent="0" marL="0">
@@ -9302,7 +9302,7 @@
                 <a:ea typeface="Arial" pitchFamily="34" charset="-122"/>
                 <a:cs typeface="Arial" pitchFamily="34" charset="-120"/>
               </a:rPr>
-              <a:t>• Continue REPAIR framework with monthly data reviews
+              <a:t>• REPAIR framework with monthly data reviews
 </a:t>
             </a:r>
             <a:pPr indent="0" marL="0">
@@ -9392,7 +9392,7 @@
         <p:spPr>
           <a:xfrm>
             <a:off x="3566160" y="3858768"/>
-            <a:ext cx="3566160" cy="1371600"/>
+            <a:ext cx="3566160" cy="1188720"/>
           </a:xfrm>
           <a:prstGeom prst="rect">
             <a:avLst/>
@@ -9431,7 +9431,7 @@
                 <a:ea typeface="Arial" pitchFamily="34" charset="-122"/>
                 <a:cs typeface="Arial" pitchFamily="34" charset="-120"/>
               </a:rPr>
-              <a:t>• Graham: 350 jobs (12.3D) — Brown: 303 jobs (14.5D)
+              <a:t>• Graham: 350 (12.3D) | Brown: 303 (14.5D)
 </a:t>
             </a:r>
             <a:pPr indent="0" marL="0">
@@ -9446,7 +9446,7 @@
                 <a:ea typeface="Arial" pitchFamily="34" charset="-122"/>
                 <a:cs typeface="Arial" pitchFamily="34" charset="-120"/>
               </a:rPr>
-              <a:t>• Parts ordered: 133 | Waiting visit: 98 | Reschedule: 31
+              <a:t>• Top: Parts ordered (133), Waiting visit (98), Reschedule (31)
 </a:t>
             </a:r>
             <a:pPr indent="0" marL="0">
@@ -9477,7 +9477,7 @@
         <p:spPr>
           <a:xfrm>
             <a:off x="7772400" y="3584448"/>
-            <a:ext cx="3749040" cy="228600"/>
+            <a:ext cx="4114800" cy="228600"/>
           </a:xfrm>
           <a:prstGeom prst="rect">
             <a:avLst/>
@@ -9497,7 +9497,7 @@
         <p:spPr>
           <a:xfrm>
             <a:off x="7772400" y="3584448"/>
-            <a:ext cx="3749040" cy="228600"/>
+            <a:ext cx="4114800" cy="228600"/>
           </a:xfrm>
           <a:prstGeom prst="rect">
             <a:avLst/>
@@ -9536,7 +9536,7 @@
         <p:spPr>
           <a:xfrm>
             <a:off x="7863840" y="3858768"/>
-            <a:ext cx="3566160" cy="1371600"/>
+            <a:ext cx="3931920" cy="1188720"/>
           </a:xfrm>
           <a:prstGeom prst="rect">
             <a:avLst/>
@@ -9605,7 +9605,7 @@
                 <a:ea typeface="Arial" pitchFamily="34" charset="-122"/>
                 <a:cs typeface="Arial" pitchFamily="34" charset="-120"/>
               </a:rPr>
-              <a:t>• Parts ordering largest driver (133 jobs) — supply chain alignment
+              <a:t>• Parts ordering (133 jobs) — supply chain alignment
 </a:t>
             </a:r>
             <a:endParaRPr lang="en-US" sz="800" dirty="0"/>
@@ -9659,7 +9659,7 @@
                 <a:ea typeface="Arial" pitchFamily="34" charset="-122"/>
                 <a:cs typeface="Arial" pitchFamily="34" charset="-120"/>
               </a:rPr>
-              <a:t>A-OK 25.8→21.4D | Ares 35.3→11.0D | Bergman 25.1→14.8D | Ernie Krygier 21.9→16.6D | Central KS 13.9→11.2D | Disaster 16.7→10.0D</a:t>
+              <a:t>A-OK 25.8&gt;21.4D | Ares 35.3&gt;11.0D | Bergman 25.1&gt;14.8D | Ernie Krygier 21.9&gt;16.6D | Central KS 13.9&gt;11.2D | Disaster 16.7&gt;10.0D</a:t>
             </a:r>
             <a:endParaRPr lang="en-US" sz="700" dirty="0"/>
           </a:p>

</xml_diff>

<commit_message>
update RTAT/pending strategy + review sections, add manager cheat sheet
</commit_message>
<xml_diff>
--- a/MBR_VersionA_Template.pptx
+++ b/MBR_VersionA_Template.pptx
@@ -1025,6 +1025,10 @@
             <a:prstDash val="solid"/>
           </a:ln>
         </p:spPr>
+        <p:txBody>
+          <a:bodyPr/>
+          <a:p/>
+        </p:txBody>
       </p:sp>
       <p:sp>
         <p:nvSpPr>
@@ -1087,6 +1091,10 @@
             <a:prstDash val="solid"/>
           </a:ln>
         </p:spPr>
+        <p:txBody>
+          <a:bodyPr/>
+          <a:p/>
+        </p:txBody>
       </p:sp>
       <p:sp>
         <p:nvSpPr>
@@ -5636,6 +5644,10 @@
             <a:prstDash val="solid"/>
           </a:ln>
         </p:spPr>
+        <p:txBody>
+          <a:bodyPr/>
+          <a:p/>
+        </p:txBody>
       </p:sp>
       <p:sp>
         <p:nvSpPr>
@@ -5659,6 +5671,10 @@
             <a:prstDash val="solid"/>
           </a:ln>
         </p:spPr>
+        <p:txBody>
+          <a:bodyPr/>
+          <a:p/>
+        </p:txBody>
       </p:sp>
       <p:sp>
         <p:nvSpPr>
@@ -5721,6 +5737,10 @@
             <a:prstDash val="solid"/>
           </a:ln>
         </p:spPr>
+        <p:txBody>
+          <a:bodyPr/>
+          <a:p/>
+        </p:txBody>
       </p:sp>
       <p:sp>
         <p:nvSpPr>
@@ -5783,6 +5803,10 @@
             <a:prstDash val="solid"/>
           </a:ln>
         </p:spPr>
+        <p:txBody>
+          <a:bodyPr/>
+          <a:p/>
+        </p:txBody>
       </p:sp>
       <p:sp>
         <p:nvSpPr>
@@ -5806,6 +5830,10 @@
             <a:prstDash val="solid"/>
           </a:ln>
         </p:spPr>
+        <p:txBody>
+          <a:bodyPr/>
+          <a:p/>
+        </p:txBody>
       </p:sp>
       <p:sp>
         <p:nvSpPr>
@@ -8052,246 +8080,6 @@
       </p:sp>
       <p:sp>
         <p:nvSpPr>
-          <p:cNvPr id="23" name="Text 18"/>
-          <p:cNvSpPr/>
-          <p:nvPr/>
-        </p:nvSpPr>
-        <p:spPr>
-          <a:xfrm>
-            <a:off x="640080" y="4928616"/>
-            <a:ext cx="5120640" cy="164592"/>
-          </a:xfrm>
-          <a:prstGeom prst="rect">
-            <a:avLst/>
-          </a:prstGeom>
-          <a:noFill/>
-          <a:ln/>
-        </p:spPr>
-        <p:txBody>
-          <a:bodyPr wrap="square" rtlCol="0" anchor="ctr"/>
-          <a:lstStyle/>
-          <a:p>
-            <a:pPr indent="0" marL="0">
-              <a:buNone/>
-            </a:pPr>
-            <a:r>
-              <a:rPr lang="en-US" sz="800" dirty="0">
-                <a:solidFill>
-                  <a:srgbClr val="000000"/>
-                </a:solidFill>
-                <a:latin typeface="Arial" pitchFamily="34" charset="0"/>
-                <a:ea typeface="Arial" pitchFamily="34" charset="-122"/>
-                <a:cs typeface="Arial" pitchFamily="34" charset="-120"/>
-              </a:rPr>
-              <a:t>▪  Urban: 93 top-10 pending, 10.6D avg delay</a:t>
-            </a:r>
-            <a:endParaRPr lang="en-US" sz="800" dirty="0"/>
-          </a:p>
-        </p:txBody>
-      </p:sp>
-      <p:sp>
-        <p:nvSpPr>
-          <p:cNvPr id="24" name="Text 19"/>
-          <p:cNvSpPr/>
-          <p:nvPr/>
-        </p:nvSpPr>
-        <p:spPr>
-          <a:xfrm>
-            <a:off x="640080" y="5111496"/>
-            <a:ext cx="5120640" cy="164592"/>
-          </a:xfrm>
-          <a:prstGeom prst="rect">
-            <a:avLst/>
-          </a:prstGeom>
-          <a:noFill/>
-          <a:ln/>
-        </p:spPr>
-        <p:txBody>
-          <a:bodyPr wrap="square" rtlCol="0" anchor="ctr"/>
-          <a:lstStyle/>
-          <a:p>
-            <a:pPr indent="0" marL="0">
-              <a:buNone/>
-            </a:pPr>
-            <a:r>
-              <a:rPr lang="en-US" sz="800" dirty="0">
-                <a:solidFill>
-                  <a:srgbClr val="000000"/>
-                </a:solidFill>
-                <a:latin typeface="Arial" pitchFamily="34" charset="0"/>
-                <a:ea typeface="Arial" pitchFamily="34" charset="-122"/>
-                <a:cs typeface="Arial" pitchFamily="34" charset="-120"/>
-              </a:rPr>
-              <a:t>▪  Rural: 53 top-10 pending, 17.4D avg delay</a:t>
-            </a:r>
-            <a:endParaRPr lang="en-US" sz="800" dirty="0"/>
-          </a:p>
-        </p:txBody>
-      </p:sp>
-      <p:sp>
-        <p:nvSpPr>
-          <p:cNvPr id="25" name="Text 20"/>
-          <p:cNvSpPr/>
-          <p:nvPr/>
-        </p:nvSpPr>
-        <p:spPr>
-          <a:xfrm>
-            <a:off x="640080" y="5294376"/>
-            <a:ext cx="5120640" cy="164592"/>
-          </a:xfrm>
-          <a:prstGeom prst="rect">
-            <a:avLst/>
-          </a:prstGeom>
-          <a:noFill/>
-          <a:ln/>
-        </p:spPr>
-        <p:txBody>
-          <a:bodyPr wrap="square" rtlCol="0" anchor="ctr"/>
-          <a:lstStyle/>
-          <a:p>
-            <a:pPr indent="0" marL="0">
-              <a:buNone/>
-            </a:pPr>
-            <a:r>
-              <a:rPr lang="en-US" sz="800" dirty="0">
-                <a:solidFill>
-                  <a:srgbClr val="000000"/>
-                </a:solidFill>
-                <a:latin typeface="Arial" pitchFamily="34" charset="0"/>
-                <a:ea typeface="Arial" pitchFamily="34" charset="-122"/>
-                <a:cs typeface="Arial" pitchFamily="34" charset="-120"/>
-              </a:rPr>
-              <a:t>▪  </a:t>
-            </a:r>
-            <a:pPr indent="0" marL="0">
-              <a:buNone/>
-            </a:pPr>
-            <a:r>
-              <a:rPr lang="en-US" sz="800" dirty="0">
-                <a:solidFill>
-                  <a:srgbClr val="000000"/>
-                </a:solidFill>
-                <a:latin typeface="Arial" pitchFamily="34" charset="0"/>
-                <a:ea typeface="Arial" pitchFamily="34" charset="-122"/>
-                <a:cs typeface="Arial" pitchFamily="34" charset="-120"/>
-              </a:rPr>
-              <a:t>Appliance Medic: </a:t>
-            </a:r>
-            <a:pPr indent="0" marL="0">
-              <a:buNone/>
-            </a:pPr>
-            <a:r>
-              <a:rPr lang="en-US" sz="800" b="1" dirty="0">
-                <a:solidFill>
-                  <a:srgbClr val="CC0000"/>
-                </a:solidFill>
-                <a:latin typeface="Arial" pitchFamily="34" charset="0"/>
-                <a:ea typeface="Arial" pitchFamily="34" charset="-122"/>
-                <a:cs typeface="Arial" pitchFamily="34" charset="-120"/>
-              </a:rPr>
-              <a:t>59.8D</a:t>
-            </a:r>
-            <a:pPr indent="0" marL="0">
-              <a:buNone/>
-            </a:pPr>
-            <a:r>
-              <a:rPr lang="en-US" sz="800" dirty="0">
-                <a:solidFill>
-                  <a:srgbClr val="000000"/>
-                </a:solidFill>
-                <a:latin typeface="Arial" pitchFamily="34" charset="0"/>
-                <a:ea typeface="Arial" pitchFamily="34" charset="-122"/>
-                <a:cs typeface="Arial" pitchFamily="34" charset="-120"/>
-              </a:rPr>
-              <a:t> avg delay</a:t>
-            </a:r>
-            <a:endParaRPr lang="en-US" sz="800" dirty="0"/>
-          </a:p>
-        </p:txBody>
-      </p:sp>
-      <p:sp>
-        <p:nvSpPr>
-          <p:cNvPr id="26" name="Text 21"/>
-          <p:cNvSpPr/>
-          <p:nvPr/>
-        </p:nvSpPr>
-        <p:spPr>
-          <a:xfrm>
-            <a:off x="640080" y="5477256"/>
-            <a:ext cx="5120640" cy="164592"/>
-          </a:xfrm>
-          <a:prstGeom prst="rect">
-            <a:avLst/>
-          </a:prstGeom>
-          <a:noFill/>
-          <a:ln/>
-        </p:spPr>
-        <p:txBody>
-          <a:bodyPr wrap="square" rtlCol="0" anchor="ctr"/>
-          <a:lstStyle/>
-          <a:p>
-            <a:pPr indent="0" marL="0">
-              <a:buNone/>
-            </a:pPr>
-            <a:r>
-              <a:rPr lang="en-US" sz="800" dirty="0">
-                <a:solidFill>
-                  <a:srgbClr val="000000"/>
-                </a:solidFill>
-                <a:latin typeface="Arial" pitchFamily="34" charset="0"/>
-                <a:ea typeface="Arial" pitchFamily="34" charset="-122"/>
-                <a:cs typeface="Arial" pitchFamily="34" charset="-120"/>
-              </a:rPr>
-              <a:t>▪  </a:t>
-            </a:r>
-            <a:pPr indent="0" marL="0">
-              <a:buNone/>
-            </a:pPr>
-            <a:r>
-              <a:rPr lang="en-US" sz="800" dirty="0">
-                <a:solidFill>
-                  <a:srgbClr val="000000"/>
-                </a:solidFill>
-                <a:latin typeface="Arial" pitchFamily="34" charset="0"/>
-                <a:ea typeface="Arial" pitchFamily="34" charset="-122"/>
-                <a:cs typeface="Arial" pitchFamily="34" charset="-120"/>
-              </a:rPr>
-              <a:t>TV Specialty Shop: </a:t>
-            </a:r>
-            <a:pPr indent="0" marL="0">
-              <a:buNone/>
-            </a:pPr>
-            <a:r>
-              <a:rPr lang="en-US" sz="800" b="1" dirty="0">
-                <a:solidFill>
-                  <a:srgbClr val="CC0000"/>
-                </a:solidFill>
-                <a:latin typeface="Arial" pitchFamily="34" charset="0"/>
-                <a:ea typeface="Arial" pitchFamily="34" charset="-122"/>
-                <a:cs typeface="Arial" pitchFamily="34" charset="-120"/>
-              </a:rPr>
-              <a:t>24.8D</a:t>
-            </a:r>
-            <a:pPr indent="0" marL="0">
-              <a:buNone/>
-            </a:pPr>
-            <a:r>
-              <a:rPr lang="en-US" sz="800" dirty="0">
-                <a:solidFill>
-                  <a:srgbClr val="000000"/>
-                </a:solidFill>
-                <a:latin typeface="Arial" pitchFamily="34" charset="0"/>
-                <a:ea typeface="Arial" pitchFamily="34" charset="-122"/>
-                <a:cs typeface="Arial" pitchFamily="34" charset="-120"/>
-              </a:rPr>
-              <a:t> avg delay</a:t>
-            </a:r>
-            <a:endParaRPr lang="en-US" sz="800" dirty="0"/>
-          </a:p>
-        </p:txBody>
-      </p:sp>
-      <p:sp>
-        <p:nvSpPr>
           <p:cNvPr id="27" name="Text 22"/>
           <p:cNvSpPr/>
           <p:nvPr/>
@@ -8324,6 +8112,45 @@
                 <a:cs typeface="Arial" pitchFamily="34" charset="-120"/>
               </a:rPr>
               <a:t>☐   RTAT Strategy</a:t>
+            </a:r>
+            <a:endParaRPr lang="en-US" sz="1000" dirty="0"/>
+          </a:p>
+        </p:txBody>
+      </p:sp>
+      <p:sp>
+        <p:nvSpPr>
+          <p:cNvPr id="35" name="Text 30"/>
+          <p:cNvSpPr/>
+          <p:nvPr/>
+        </p:nvSpPr>
+        <p:spPr>
+          <a:xfrm>
+            <a:off x="6400800" y="4352544"/>
+            <a:ext cx="5303520" cy="210312"/>
+          </a:xfrm>
+          <a:prstGeom prst="rect">
+            <a:avLst/>
+          </a:prstGeom>
+          <a:noFill/>
+          <a:ln/>
+        </p:spPr>
+        <p:txBody>
+          <a:bodyPr wrap="square" rtlCol="0" anchor="ctr"/>
+          <a:lstStyle/>
+          <a:p>
+            <a:pPr indent="0" marL="0">
+              <a:buNone/>
+            </a:pPr>
+            <a:r>
+              <a:rPr lang="en-US" sz="1000" b="1" dirty="0">
+                <a:solidFill>
+                  <a:srgbClr val="000000"/>
+                </a:solidFill>
+                <a:latin typeface="Arial" pitchFamily="34" charset="0"/>
+                <a:ea typeface="Arial" pitchFamily="34" charset="-122"/>
+                <a:cs typeface="Arial" pitchFamily="34" charset="-120"/>
+              </a:rPr>
+              <a:t>☐   Pending Strategy</a:t>
             </a:r>
             <a:endParaRPr lang="en-US" sz="1000" dirty="0"/>
           </a:p>
@@ -8370,7 +8197,7 @@
       </p:sp>
       <p:sp>
         <p:nvSpPr>
-          <p:cNvPr id="29" name="Text 24"/>
+          <p:cNvPr id="28" name="Text 23"/>
           <p:cNvSpPr/>
           <p:nvPr/>
         </p:nvSpPr>
@@ -8393,9 +8220,9 @@
               <a:buNone/>
             </a:pPr>
             <a:r>
-              <a:rPr lang="en-US" sz="700" dirty="0">
+              <a:rPr lang="en-US" sz="800" b="1" dirty="0">
                 <a:solidFill>
-                  <a:srgbClr val="999999"/>
+                  <a:srgbClr val="000000"/>
                 </a:solidFill>
                 <a:latin typeface="Arial" pitchFamily="34" charset="0"/>
                 <a:ea typeface="Arial" pitchFamily="34" charset="-122"/>
@@ -8403,13 +8230,13 @@
               </a:rPr>
               <a:t>▪      Rank  |  Establish  |  Process  |  Amplify  |  Integrate  |  Redirect</a:t>
             </a:r>
-            <a:endParaRPr lang="en-US" sz="700" dirty="0"/>
+            <a:endParaRPr lang="en-US" sz="800" dirty="0"/>
           </a:p>
         </p:txBody>
       </p:sp>
       <p:sp>
         <p:nvSpPr>
-          <p:cNvPr id="30" name="Text 25"/>
+          <p:cNvPr id="28" name="Text 23"/>
           <p:cNvSpPr/>
           <p:nvPr/>
         </p:nvSpPr>
@@ -8440,7 +8267,7 @@
                 <a:ea typeface="Arial" pitchFamily="34" charset="-122"/>
                 <a:cs typeface="Arial" pitchFamily="34" charset="-120"/>
               </a:rPr>
-              <a:t>▪  10D target — once met, move to 8D</a:t>
+              <a:t>▪  Shifting to rural-heavy focus — Urban hit 9.7D (below 10D target)</a:t>
             </a:r>
             <a:endParaRPr lang="en-US" sz="800" dirty="0"/>
           </a:p>
@@ -8448,13 +8275,169 @@
       </p:sp>
       <p:sp>
         <p:nvSpPr>
-          <p:cNvPr id="31" name="Text 26"/>
+          <p:cNvPr id="28" name="Text 23"/>
           <p:cNvSpPr/>
           <p:nvPr/>
         </p:nvSpPr>
         <p:spPr>
           <a:xfrm>
             <a:off x="6583680" y="3529584"/>
+            <a:ext cx="5120640" cy="164592"/>
+          </a:xfrm>
+          <a:prstGeom prst="rect">
+            <a:avLst/>
+          </a:prstGeom>
+          <a:noFill/>
+          <a:ln/>
+        </p:spPr>
+        <p:txBody>
+          <a:bodyPr wrap="square" rtlCol="0" anchor="ctr"/>
+          <a:lstStyle/>
+          <a:p>
+            <a:pPr indent="0" marL="0">
+              <a:buNone/>
+            </a:pPr>
+            <a:r>
+              <a:rPr lang="en-US" sz="800" b="1" dirty="0">
+                <a:solidFill>
+                  <a:srgbClr val="000000"/>
+                </a:solidFill>
+                <a:latin typeface="Arial" pitchFamily="34" charset="0"/>
+                <a:ea typeface="Arial" pitchFamily="34" charset="-122"/>
+                <a:cs typeface="Arial" pitchFamily="34" charset="-120"/>
+              </a:rPr>
+              <a:t>▪  Continue holding Urban below 10D while driving Rural to 10D</a:t>
+            </a:r>
+            <a:endParaRPr lang="en-US" sz="800" dirty="0"/>
+          </a:p>
+        </p:txBody>
+      </p:sp>
+      <p:sp>
+        <p:nvSpPr>
+          <p:cNvPr id="28" name="Text 23"/>
+          <p:cNvSpPr/>
+          <p:nvPr/>
+        </p:nvSpPr>
+        <p:spPr>
+          <a:xfrm>
+            <a:off x="6583680" y="3712464"/>
+            <a:ext cx="5120640" cy="164592"/>
+          </a:xfrm>
+          <a:prstGeom prst="rect">
+            <a:avLst/>
+          </a:prstGeom>
+          <a:noFill/>
+          <a:ln/>
+        </p:spPr>
+        <p:txBody>
+          <a:bodyPr wrap="square" rtlCol="0" anchor="ctr"/>
+          <a:lstStyle/>
+          <a:p>
+            <a:pPr indent="0" marL="0">
+              <a:buNone/>
+            </a:pPr>
+            <a:r>
+              <a:rPr lang="en-US" sz="800" b="1" dirty="0">
+                <a:solidFill>
+                  <a:srgbClr val="000000"/>
+                </a:solidFill>
+                <a:latin typeface="Arial" pitchFamily="34" charset="0"/>
+                <a:ea typeface="Arial" pitchFamily="34" charset="-122"/>
+                <a:cs typeface="Arial" pitchFamily="34" charset="-120"/>
+              </a:rPr>
+              <a:t>▪  Once 10D met across both markets, target moves to 8D before peak season</a:t>
+            </a:r>
+            <a:endParaRPr lang="en-US" sz="800" dirty="0"/>
+          </a:p>
+        </p:txBody>
+      </p:sp>
+      <p:sp>
+        <p:nvSpPr>
+          <p:cNvPr id="28" name="Text 23"/>
+          <p:cNvSpPr/>
+          <p:nvPr/>
+        </p:nvSpPr>
+        <p:spPr>
+          <a:xfrm>
+            <a:off x="6583680" y="3895344"/>
+            <a:ext cx="5120640" cy="164592"/>
+          </a:xfrm>
+          <a:prstGeom prst="rect">
+            <a:avLst/>
+          </a:prstGeom>
+          <a:noFill/>
+          <a:ln/>
+        </p:spPr>
+        <p:txBody>
+          <a:bodyPr wrap="square" rtlCol="0" anchor="ctr"/>
+          <a:lstStyle/>
+          <a:p>
+            <a:pPr indent="0" marL="0">
+              <a:buNone/>
+            </a:pPr>
+            <a:r>
+              <a:rPr lang="en-US" sz="800" b="1" dirty="0">
+                <a:solidFill>
+                  <a:srgbClr val="000000"/>
+                </a:solidFill>
+                <a:latin typeface="Arial" pitchFamily="34" charset="0"/>
+                <a:ea typeface="Arial" pitchFamily="34" charset="-122"/>
+                <a:cs typeface="Arial" pitchFamily="34" charset="-120"/>
+              </a:rPr>
+              <a:t>▪  Dynamic Top 10: rank ASCs by volume × RTAT gap, apply REPAIR,</a:t>
+            </a:r>
+            <a:endParaRPr lang="en-US" sz="800" dirty="0"/>
+          </a:p>
+        </p:txBody>
+      </p:sp>
+      <p:sp>
+        <p:nvSpPr>
+          <p:cNvPr id="28" name="Text 23"/>
+          <p:cNvSpPr/>
+          <p:nvPr/>
+        </p:nvSpPr>
+        <p:spPr>
+          <a:xfrm>
+            <a:off x="6583680" y="4078224"/>
+            <a:ext cx="5120640" cy="164592"/>
+          </a:xfrm>
+          <a:prstGeom prst="rect">
+            <a:avLst/>
+          </a:prstGeom>
+          <a:noFill/>
+          <a:ln/>
+        </p:spPr>
+        <p:txBody>
+          <a:bodyPr wrap="square" rtlCol="0" anchor="ctr"/>
+          <a:lstStyle/>
+          <a:p>
+            <a:pPr indent="0" marL="0">
+              <a:buNone/>
+            </a:pPr>
+            <a:r>
+              <a:rPr lang="en-US" sz="800" b="1" dirty="0">
+                <a:solidFill>
+                  <a:srgbClr val="000000"/>
+                </a:solidFill>
+                <a:latin typeface="Arial" pitchFamily="34" charset="0"/>
+                <a:ea typeface="Arial" pitchFamily="34" charset="-122"/>
+                <a:cs typeface="Arial" pitchFamily="34" charset="-120"/>
+              </a:rPr>
+              <a:t>▪  cycle list as accounts stabilize and new ones surface</a:t>
+            </a:r>
+            <a:endParaRPr lang="en-US" sz="800" dirty="0"/>
+          </a:p>
+        </p:txBody>
+      </p:sp>
+      <p:sp>
+        <p:nvSpPr>
+          <p:cNvPr id="23" name="Text 18"/>
+          <p:cNvSpPr/>
+          <p:nvPr/>
+        </p:nvSpPr>
+        <p:spPr>
+          <a:xfrm>
+            <a:off x="640080" y="4928616"/>
             <a:ext cx="5120640" cy="164592"/>
           </a:xfrm>
           <a:prstGeom prst="rect">
@@ -8479,7 +8462,7 @@
                 <a:ea typeface="Arial" pitchFamily="34" charset="-122"/>
                 <a:cs typeface="Arial" pitchFamily="34" charset="-120"/>
               </a:rPr>
-              <a:t>▪  Selecting new focus ASCs for handed-off accounts</a:t>
+              <a:t>▪  Started at ~16% of pending at 30+ days when we took over</a:t>
             </a:r>
             <a:endParaRPr lang="en-US" sz="800" dirty="0"/>
           </a:p>
@@ -8487,13 +8470,13 @@
       </p:sp>
       <p:sp>
         <p:nvSpPr>
-          <p:cNvPr id="32" name="Text 27"/>
+          <p:cNvPr id="23" name="Text 18"/>
           <p:cNvSpPr/>
           <p:nvPr/>
         </p:nvSpPr>
         <p:spPr>
           <a:xfrm>
-            <a:off x="6583680" y="3712464"/>
+            <a:off x="640080" y="5111496"/>
             <a:ext cx="5120640" cy="164592"/>
           </a:xfrm>
           <a:prstGeom prst="rect">
@@ -8518,63 +8501,7 @@
                 <a:ea typeface="Arial" pitchFamily="34" charset="-122"/>
                 <a:cs typeface="Arial" pitchFamily="34" charset="-120"/>
               </a:rPr>
-              <a:t>▪  </a:t>
-            </a:r>
-            <a:pPr indent="0" marL="0">
-              <a:buNone/>
-            </a:pPr>
-            <a:r>
-              <a:rPr lang="en-US" sz="800" dirty="0">
-                <a:solidFill>
-                  <a:srgbClr val="000000"/>
-                </a:solidFill>
-                <a:latin typeface="Arial" pitchFamily="34" charset="0"/>
-                <a:ea typeface="Arial" pitchFamily="34" charset="-122"/>
-                <a:cs typeface="Arial" pitchFamily="34" charset="-120"/>
-              </a:rPr>
-              <a:t>Engage: Doctor Maint </a:t>
-            </a:r>
-            <a:pPr indent="0" marL="0">
-              <a:buNone/>
-            </a:pPr>
-            <a:r>
-              <a:rPr lang="en-US" sz="800" b="1" dirty="0">
-                <a:solidFill>
-                  <a:srgbClr val="CC0000"/>
-                </a:solidFill>
-                <a:latin typeface="Arial" pitchFamily="34" charset="0"/>
-                <a:ea typeface="Arial" pitchFamily="34" charset="-122"/>
-                <a:cs typeface="Arial" pitchFamily="34" charset="-120"/>
-              </a:rPr>
-              <a:t>(37.0D)</a:t>
-            </a:r>
-            <a:pPr indent="0" marL="0">
-              <a:buNone/>
-            </a:pPr>
-            <a:r>
-              <a:rPr lang="en-US" sz="800" dirty="0">
-                <a:solidFill>
-                  <a:srgbClr val="000000"/>
-                </a:solidFill>
-                <a:latin typeface="Arial" pitchFamily="34" charset="0"/>
-                <a:ea typeface="Arial" pitchFamily="34" charset="-122"/>
-                <a:cs typeface="Arial" pitchFamily="34" charset="-120"/>
-              </a:rPr>
-              <a:t>, Keisers </a:t>
-            </a:r>
-            <a:pPr indent="0" marL="0">
-              <a:buNone/>
-            </a:pPr>
-            <a:r>
-              <a:rPr lang="en-US" sz="800" b="1" dirty="0">
-                <a:solidFill>
-                  <a:srgbClr val="CC0000"/>
-                </a:solidFill>
-                <a:latin typeface="Arial" pitchFamily="34" charset="0"/>
-                <a:ea typeface="Arial" pitchFamily="34" charset="-122"/>
-                <a:cs typeface="Arial" pitchFamily="34" charset="-120"/>
-              </a:rPr>
-              <a:t>(30.9D)</a:t>
+              <a:t>▪  Now at ~9.4% combined (Graham 7.6%, Brown 11.4%)</a:t>
             </a:r>
             <a:endParaRPr lang="en-US" sz="800" dirty="0"/>
           </a:p>
@@ -8582,13 +8509,13 @@
       </p:sp>
       <p:sp>
         <p:nvSpPr>
-          <p:cNvPr id="33" name="Text 28"/>
+          <p:cNvPr id="23" name="Text 18"/>
           <p:cNvSpPr/>
           <p:nvPr/>
         </p:nvSpPr>
         <p:spPr>
           <a:xfrm>
-            <a:off x="6583680" y="3895344"/>
+            <a:off x="640080" y="5294376"/>
             <a:ext cx="5120640" cy="164592"/>
           </a:xfrm>
           <a:prstGeom prst="rect">
@@ -8613,7 +8540,7 @@
                 <a:ea typeface="Arial" pitchFamily="34" charset="-122"/>
                 <a:cs typeface="Arial" pitchFamily="34" charset="-120"/>
               </a:rPr>
-              <a:t>▪  Urban: hold 10D, push to 8D by Q3</a:t>
+              <a:t>▪  Total pending: 1,888 → 1,570 (W8→W12)</a:t>
             </a:r>
             <a:endParaRPr lang="en-US" sz="800" dirty="0"/>
           </a:p>
@@ -8621,13 +8548,13 @@
       </p:sp>
       <p:sp>
         <p:nvSpPr>
-          <p:cNvPr id="34" name="Text 29"/>
+          <p:cNvPr id="23" name="Text 18"/>
           <p:cNvSpPr/>
           <p:nvPr/>
         </p:nvSpPr>
         <p:spPr>
           <a:xfrm>
-            <a:off x="6583680" y="4078224"/>
+            <a:off x="640080" y="5477256"/>
             <a:ext cx="5120640" cy="164592"/>
           </a:xfrm>
           <a:prstGeom prst="rect">
@@ -8652,7 +8579,7 @@
                 <a:ea typeface="Arial" pitchFamily="34" charset="-122"/>
                 <a:cs typeface="Arial" pitchFamily="34" charset="-120"/>
               </a:rPr>
-              <a:t>▪  Rural: 11D by Q2, 10D by Q3</a:t>
+              <a:t>▪  Avg pending age: 12.9D combined, trending down</a:t>
             </a:r>
             <a:endParaRPr lang="en-US" sz="800" dirty="0"/>
           </a:p>
@@ -8660,14 +8587,14 @@
       </p:sp>
       <p:sp>
         <p:nvSpPr>
-          <p:cNvPr id="35" name="Text 30"/>
+          <p:cNvPr id="23" name="Text 18"/>
           <p:cNvSpPr/>
           <p:nvPr/>
         </p:nvSpPr>
         <p:spPr>
           <a:xfrm>
-            <a:off x="6400800" y="4352544"/>
-            <a:ext cx="5303520" cy="210312"/>
+            <a:off x="640080" y="5660136"/>
+            <a:ext cx="5120640" cy="164592"/>
           </a:xfrm>
           <a:prstGeom prst="rect">
             <a:avLst/>
@@ -8683,7 +8610,7 @@
               <a:buNone/>
             </a:pPr>
             <a:r>
-              <a:rPr lang="en-US" sz="1000" b="1" dirty="0">
+              <a:rPr lang="en-US" sz="800" dirty="0">
                 <a:solidFill>
                   <a:srgbClr val="000000"/>
                 </a:solidFill>
@@ -8691,9 +8618,9 @@
                 <a:ea typeface="Arial" pitchFamily="34" charset="-122"/>
                 <a:cs typeface="Arial" pitchFamily="34" charset="-120"/>
               </a:rPr>
-              <a:t>☐   Pending Strategy</a:t>
+              <a:t>▪  60+ day pending: 20 total — pushing toward zero</a:t>
             </a:r>
-            <a:endParaRPr lang="en-US" sz="1000" dirty="0"/>
+            <a:endParaRPr lang="en-US" sz="800" dirty="0"/>
           </a:p>
         </p:txBody>
       </p:sp>
@@ -8730,57 +8657,24 @@
                 <a:ea typeface="Arial" pitchFamily="34" charset="-122"/>
                 <a:cs typeface="Arial" pitchFamily="34" charset="-120"/>
               </a:rPr>
-              <a:t>▪  </a:t>
+              <a:t>▪  Pending managed holistically — not split by Urban/Rural</a:t>
             </a:r>
             <a:pPr indent="0" marL="0">
               <a:buNone/>
             </a:pPr>
-            <a:r>
-              <a:rPr lang="en-US" sz="800" dirty="0">
-                <a:solidFill>
-                  <a:srgbClr val="000000"/>
-                </a:solidFill>
-                <a:latin typeface="Arial" pitchFamily="34" charset="0"/>
-                <a:ea typeface="Arial" pitchFamily="34" charset="-122"/>
-                <a:cs typeface="Arial" pitchFamily="34" charset="-120"/>
-              </a:rPr>
-              <a:t>Appliance Medic </a:t>
-            </a:r>
             <a:pPr indent="0" marL="0">
               <a:buNone/>
             </a:pPr>
-            <a:r>
-              <a:rPr lang="en-US" sz="800" b="1" dirty="0">
-                <a:solidFill>
-                  <a:srgbClr val="CC0000"/>
-                </a:solidFill>
-                <a:latin typeface="Arial" pitchFamily="34" charset="0"/>
-                <a:ea typeface="Arial" pitchFamily="34" charset="-122"/>
-                <a:cs typeface="Arial" pitchFamily="34" charset="-120"/>
-              </a:rPr>
-              <a:t>59.8D</a:t>
-            </a:r>
             <a:pPr indent="0" marL="0">
               <a:buNone/>
             </a:pPr>
-            <a:r>
-              <a:rPr lang="en-US" sz="800" dirty="0">
-                <a:solidFill>
-                  <a:srgbClr val="000000"/>
-                </a:solidFill>
-                <a:latin typeface="Arial" pitchFamily="34" charset="0"/>
-                <a:ea typeface="Arial" pitchFamily="34" charset="-122"/>
-                <a:cs typeface="Arial" pitchFamily="34" charset="-120"/>
-              </a:rPr>
-              <a:t> — immediate escalation</a:t>
-            </a:r>
             <a:endParaRPr lang="en-US" sz="800" dirty="0"/>
           </a:p>
         </p:txBody>
       </p:sp>
       <p:sp>
         <p:nvSpPr>
-          <p:cNvPr id="37" name="Text 32"/>
+          <p:cNvPr id="36" name="Text 31"/>
           <p:cNvSpPr/>
           <p:nvPr/>
         </p:nvSpPr>
@@ -8811,15 +8705,24 @@
                 <a:ea typeface="Arial" pitchFamily="34" charset="-122"/>
                 <a:cs typeface="Arial" pitchFamily="34" charset="-120"/>
               </a:rPr>
-              <a:t>▪  A-OK: 16 pending — accelerate scheduling</a:t>
+              <a:t>▪  30+ day pending: ~16% → now ~9.4% (goal: 7%)</a:t>
             </a:r>
+            <a:pPr indent="0" marL="0">
+              <a:buNone/>
+            </a:pPr>
+            <a:pPr indent="0" marL="0">
+              <a:buNone/>
+            </a:pPr>
+            <a:pPr indent="0" marL="0">
+              <a:buNone/>
+            </a:pPr>
             <a:endParaRPr lang="en-US" sz="800" dirty="0"/>
           </a:p>
         </p:txBody>
       </p:sp>
       <p:sp>
         <p:nvSpPr>
-          <p:cNvPr id="38" name="Text 33"/>
+          <p:cNvPr id="36" name="Text 31"/>
           <p:cNvSpPr/>
           <p:nvPr/>
         </p:nvSpPr>
@@ -8850,8 +8753,209 @@
                 <a:ea typeface="Arial" pitchFamily="34" charset="-122"/>
                 <a:cs typeface="Arial" pitchFamily="34" charset="-120"/>
               </a:rPr>
-              <a:t>▪  Target: top-10 avg delay below 10D</a:t>
+              <a:t>▪  Push 30+ toward zero — remaining = backorder parts only</a:t>
             </a:r>
+            <a:pPr indent="0" marL="0">
+              <a:buNone/>
+            </a:pPr>
+            <a:pPr indent="0" marL="0">
+              <a:buNone/>
+            </a:pPr>
+            <a:pPr indent="0" marL="0">
+              <a:buNone/>
+            </a:pPr>
+            <a:endParaRPr lang="en-US" sz="800" dirty="0"/>
+          </a:p>
+        </p:txBody>
+      </p:sp>
+      <p:sp>
+        <p:nvSpPr>
+          <p:cNvPr id="36" name="Text 31"/>
+          <p:cNvSpPr/>
+          <p:nvPr/>
+        </p:nvSpPr>
+        <p:spPr>
+          <a:xfrm>
+            <a:off x="6583680" y="5138928"/>
+            <a:ext cx="5120640" cy="164592"/>
+          </a:xfrm>
+          <a:prstGeom prst="rect">
+            <a:avLst/>
+          </a:prstGeom>
+          <a:noFill/>
+          <a:ln/>
+        </p:spPr>
+        <p:txBody>
+          <a:bodyPr wrap="square" rtlCol="0" anchor="ctr"/>
+          <a:lstStyle/>
+          <a:p>
+            <a:pPr indent="0" marL="0">
+              <a:buNone/>
+            </a:pPr>
+            <a:r>
+              <a:rPr lang="en-US" sz="800" dirty="0">
+                <a:solidFill>
+                  <a:srgbClr val="000000"/>
+                </a:solidFill>
+                <a:latin typeface="Arial" pitchFamily="34" charset="0"/>
+                <a:ea typeface="Arial" pitchFamily="34" charset="-122"/>
+                <a:cs typeface="Arial" pitchFamily="34" charset="-120"/>
+              </a:rPr>
+              <a:t>▪  Once 30+ controlled, shift focus to 25-30 day bucket</a:t>
+            </a:r>
+            <a:pPr indent="0" marL="0">
+              <a:buNone/>
+            </a:pPr>
+            <a:pPr indent="0" marL="0">
+              <a:buNone/>
+            </a:pPr>
+            <a:pPr indent="0" marL="0">
+              <a:buNone/>
+            </a:pPr>
+            <a:endParaRPr lang="en-US" sz="800" dirty="0"/>
+          </a:p>
+        </p:txBody>
+      </p:sp>
+      <p:sp>
+        <p:nvSpPr>
+          <p:cNvPr id="36" name="Text 31"/>
+          <p:cNvSpPr/>
+          <p:nvPr/>
+        </p:nvSpPr>
+        <p:spPr>
+          <a:xfrm>
+            <a:off x="6583680" y="5321808"/>
+            <a:ext cx="5120640" cy="164592"/>
+          </a:xfrm>
+          <a:prstGeom prst="rect">
+            <a:avLst/>
+          </a:prstGeom>
+          <a:noFill/>
+          <a:ln/>
+        </p:spPr>
+        <p:txBody>
+          <a:bodyPr wrap="square" rtlCol="0" anchor="ctr"/>
+          <a:lstStyle/>
+          <a:p>
+            <a:pPr indent="0" marL="0">
+              <a:buNone/>
+            </a:pPr>
+            <a:r>
+              <a:rPr lang="en-US" sz="800" dirty="0">
+                <a:solidFill>
+                  <a:srgbClr val="000000"/>
+                </a:solidFill>
+                <a:latin typeface="Arial" pitchFamily="34" charset="0"/>
+                <a:ea typeface="Arial" pitchFamily="34" charset="-122"/>
+                <a:cs typeface="Arial" pitchFamily="34" charset="-120"/>
+              </a:rPr>
+              <a:t>▪  Daily tracking via dashboard linked to Google Sheets</a:t>
+            </a:r>
+            <a:pPr indent="0" marL="0">
+              <a:buNone/>
+            </a:pPr>
+            <a:pPr indent="0" marL="0">
+              <a:buNone/>
+            </a:pPr>
+            <a:pPr indent="0" marL="0">
+              <a:buNone/>
+            </a:pPr>
+            <a:endParaRPr lang="en-US" sz="800" dirty="0"/>
+          </a:p>
+        </p:txBody>
+      </p:sp>
+      <p:sp>
+        <p:nvSpPr>
+          <p:cNvPr id="36" name="Text 31"/>
+          <p:cNvSpPr/>
+          <p:nvPr/>
+        </p:nvSpPr>
+        <p:spPr>
+          <a:xfrm>
+            <a:off x="6583680" y="5504688"/>
+            <a:ext cx="5120640" cy="164592"/>
+          </a:xfrm>
+          <a:prstGeom prst="rect">
+            <a:avLst/>
+          </a:prstGeom>
+          <a:noFill/>
+          <a:ln/>
+        </p:spPr>
+        <p:txBody>
+          <a:bodyPr wrap="square" rtlCol="0" anchor="ctr"/>
+          <a:lstStyle/>
+          <a:p>
+            <a:pPr indent="0" marL="0">
+              <a:buNone/>
+            </a:pPr>
+            <a:r>
+              <a:rPr lang="en-US" sz="800" dirty="0">
+                <a:solidFill>
+                  <a:srgbClr val="000000"/>
+                </a:solidFill>
+                <a:latin typeface="Arial" pitchFamily="34" charset="0"/>
+                <a:ea typeface="Arial" pitchFamily="34" charset="-122"/>
+                <a:cs typeface="Arial" pitchFamily="34" charset="-120"/>
+              </a:rPr>
+              <a:t>▪  Avg pending days tracked WoW — target continuous reduction</a:t>
+            </a:r>
+            <a:pPr indent="0" marL="0">
+              <a:buNone/>
+            </a:pPr>
+            <a:pPr indent="0" marL="0">
+              <a:buNone/>
+            </a:pPr>
+            <a:pPr indent="0" marL="0">
+              <a:buNone/>
+            </a:pPr>
+            <a:endParaRPr lang="en-US" sz="800" dirty="0"/>
+          </a:p>
+        </p:txBody>
+      </p:sp>
+      <p:sp>
+        <p:nvSpPr>
+          <p:cNvPr id="36" name="Text 31"/>
+          <p:cNvSpPr/>
+          <p:nvPr/>
+        </p:nvSpPr>
+        <p:spPr>
+          <a:xfrm>
+            <a:off x="6583680" y="5687568"/>
+            <a:ext cx="5120640" cy="164592"/>
+          </a:xfrm>
+          <a:prstGeom prst="rect">
+            <a:avLst/>
+          </a:prstGeom>
+          <a:noFill/>
+          <a:ln/>
+        </p:spPr>
+        <p:txBody>
+          <a:bodyPr wrap="square" rtlCol="0" anchor="ctr"/>
+          <a:lstStyle/>
+          <a:p>
+            <a:pPr indent="0" marL="0">
+              <a:buNone/>
+            </a:pPr>
+            <a:r>
+              <a:rPr lang="en-US" sz="800" dirty="0">
+                <a:solidFill>
+                  <a:srgbClr val="000000"/>
+                </a:solidFill>
+                <a:latin typeface="Arial" pitchFamily="34" charset="0"/>
+                <a:ea typeface="Arial" pitchFamily="34" charset="-122"/>
+                <a:cs typeface="Arial" pitchFamily="34" charset="-120"/>
+              </a:rPr>
+              <a:t>▪  Top 10 ASC avg pending age target: below 10 days</a:t>
+            </a:r>
+            <a:pPr indent="0" marL="0">
+              <a:buNone/>
+            </a:pPr>
+            <a:pPr indent="0" marL="0">
+              <a:buNone/>
+            </a:pPr>
+            <a:pPr indent="0" marL="0">
+              <a:buNone/>
+            </a:pPr>
             <a:endParaRPr lang="en-US" sz="800" dirty="0"/>
           </a:p>
         </p:txBody>

</xml_diff>